<commit_message>
Polish public assets and authorship
</commit_message>
<xml_diff>
--- a/docs/outputs/loneliness_risk_research_deck.pptx
+++ b/docs/outputs/loneliness_risk_research_deck.pptx
@@ -2792,7 +2792,7 @@
                   <a:srgbClr val="5B6472"/>
                 </a:solidFill>
               </a:rPr>
-              <a:t>Loneliness &amp; Risk Decision Lab</a:t>
+              <a:t>Developed by He Haoze (何昊泽)</a:t>
             </a:r>
           </a:p>
         </p:txBody>
@@ -3753,7 +3753,7 @@
                   <a:srgbClr val="5B6472"/>
                 </a:solidFill>
               </a:rPr>
-              <a:t>Loneliness &amp; Risk Decision Lab</a:t>
+              <a:t>Developed by He Haoze (何昊泽)</a:t>
             </a:r>
           </a:p>
         </p:txBody>
@@ -4796,7 +4796,7 @@
                   <a:srgbClr val="5B6472"/>
                 </a:solidFill>
               </a:rPr>
-              <a:t>Loneliness &amp; Risk Decision Lab</a:t>
+              <a:t>Developed by He Haoze (何昊泽)</a:t>
             </a:r>
           </a:p>
         </p:txBody>
@@ -5856,7 +5856,7 @@
                   <a:srgbClr val="5B6472"/>
                 </a:solidFill>
               </a:rPr>
-              <a:t>Loneliness &amp; Risk Decision Lab</a:t>
+              <a:t>Developed by He Haoze (何昊泽)</a:t>
             </a:r>
           </a:p>
         </p:txBody>
@@ -6817,7 +6817,7 @@
                   <a:srgbClr val="5B6472"/>
                 </a:solidFill>
               </a:rPr>
-              <a:t>Loneliness &amp; Risk Decision Lab</a:t>
+              <a:t>Developed by He Haoze (何昊泽)</a:t>
             </a:r>
           </a:p>
         </p:txBody>
@@ -7295,7 +7295,7 @@
                   <a:srgbClr val="5B6472"/>
                 </a:solidFill>
               </a:rPr>
-              <a:t>Loneliness &amp; Risk Decision Lab</a:t>
+              <a:t>Developed by He Haoze (何昊泽)</a:t>
             </a:r>
           </a:p>
         </p:txBody>
@@ -7773,7 +7773,7 @@
                   <a:srgbClr val="5B6472"/>
                 </a:solidFill>
               </a:rPr>
-              <a:t>Loneliness &amp; Risk Decision Lab</a:t>
+              <a:t>Developed by He Haoze (何昊泽)</a:t>
             </a:r>
           </a:p>
         </p:txBody>
@@ -8518,7 +8518,7 @@
                   <a:srgbClr val="5B6472"/>
                 </a:solidFill>
               </a:rPr>
-              <a:t>Loneliness &amp; Risk Decision Lab</a:t>
+              <a:t>Developed by He Haoze (何昊泽)</a:t>
             </a:r>
           </a:p>
         </p:txBody>
@@ -9279,7 +9279,7 @@
                   <a:srgbClr val="5B6472"/>
                 </a:solidFill>
               </a:rPr>
-              <a:t>Loneliness &amp; Risk Decision Lab</a:t>
+              <a:t>Developed by He Haoze (何昊泽)</a:t>
             </a:r>
           </a:p>
         </p:txBody>
@@ -10474,7 +10474,7 @@
                   <a:srgbClr val="5B6472"/>
                 </a:solidFill>
               </a:rPr>
-              <a:t>Loneliness &amp; Risk Decision Lab</a:t>
+              <a:t>Developed by He Haoze (何昊泽)</a:t>
             </a:r>
           </a:p>
         </p:txBody>

</xml_diff>

<commit_message>
Add LRDL-HHZ logo system
</commit_message>
<xml_diff>
--- a/docs/outputs/loneliness_risk_research_deck.pptx
+++ b/docs/outputs/loneliness_risk_research_deck.pptx
@@ -2847,6 +2847,30 @@
           </a:p>
         </p:txBody>
       </p:sp>
+      <p:pic>
+        <p:nvPicPr>
+          <p:cNvPr id="17" name="LRDL HHZ logo"/>
+          <p:cNvPicPr>
+            <a:picLocks xmlns:a="http://schemas.openxmlformats.org/drawingml/2006/main" noChangeAspect="1"/>
+          </p:cNvPicPr>
+          <p:nvPr/>
+        </p:nvPicPr>
+        <p:blipFill>
+          <a:blip xmlns:a="http://schemas.openxmlformats.org/drawingml/2006/main" xmlns:r="http://schemas.openxmlformats.org/officeDocument/2006/relationships" r:embed="rIdLrdlLogo"/>
+          <a:stretch xmlns:a="http://schemas.openxmlformats.org/drawingml/2006/main">
+            <a:fillRect/>
+          </a:stretch>
+        </p:blipFill>
+        <p:spPr>
+          <a:xfrm xmlns:a="http://schemas.openxmlformats.org/drawingml/2006/main">
+            <a:off x="365760" y="6267450"/>
+            <a:ext cx="342900" cy="342900"/>
+          </a:xfrm>
+          <a:prstGeom xmlns:a="http://schemas.openxmlformats.org/drawingml/2006/main" prst="rect">
+            <a:avLst/>
+          </a:prstGeom>
+        </p:spPr>
+      </p:pic>
     </p:spTree>
     <p:extLst>
       <p:ext uri="{BB962C8B-B14F-4D97-AF65-F5344CB8AC3E}">
@@ -3808,6 +3832,30 @@
           </a:p>
         </p:txBody>
       </p:sp>
+      <p:pic>
+        <p:nvPicPr>
+          <p:cNvPr id="21" name="LRDL HHZ logo"/>
+          <p:cNvPicPr>
+            <a:picLocks xmlns:a="http://schemas.openxmlformats.org/drawingml/2006/main" noChangeAspect="1"/>
+          </p:cNvPicPr>
+          <p:nvPr/>
+        </p:nvPicPr>
+        <p:blipFill>
+          <a:blip xmlns:a="http://schemas.openxmlformats.org/drawingml/2006/main" xmlns:r="http://schemas.openxmlformats.org/officeDocument/2006/relationships" r:embed="rIdLrdlLogo"/>
+          <a:stretch xmlns:a="http://schemas.openxmlformats.org/drawingml/2006/main">
+            <a:fillRect/>
+          </a:stretch>
+        </p:blipFill>
+        <p:spPr>
+          <a:xfrm xmlns:a="http://schemas.openxmlformats.org/drawingml/2006/main">
+            <a:off x="365760" y="6267450"/>
+            <a:ext cx="342900" cy="342900"/>
+          </a:xfrm>
+          <a:prstGeom xmlns:a="http://schemas.openxmlformats.org/drawingml/2006/main" prst="rect">
+            <a:avLst/>
+          </a:prstGeom>
+        </p:spPr>
+      </p:pic>
     </p:spTree>
     <p:extLst>
       <p:ext uri="{BB962C8B-B14F-4D97-AF65-F5344CB8AC3E}">
@@ -4851,6 +4899,30 @@
           </a:p>
         </p:txBody>
       </p:sp>
+      <p:pic>
+        <p:nvPicPr>
+          <p:cNvPr id="24" name="LRDL HHZ logo"/>
+          <p:cNvPicPr>
+            <a:picLocks xmlns:a="http://schemas.openxmlformats.org/drawingml/2006/main" noChangeAspect="1"/>
+          </p:cNvPicPr>
+          <p:nvPr/>
+        </p:nvPicPr>
+        <p:blipFill>
+          <a:blip xmlns:a="http://schemas.openxmlformats.org/drawingml/2006/main" xmlns:r="http://schemas.openxmlformats.org/officeDocument/2006/relationships" r:embed="rIdLrdlLogo"/>
+          <a:stretch xmlns:a="http://schemas.openxmlformats.org/drawingml/2006/main">
+            <a:fillRect/>
+          </a:stretch>
+        </p:blipFill>
+        <p:spPr>
+          <a:xfrm xmlns:a="http://schemas.openxmlformats.org/drawingml/2006/main">
+            <a:off x="365760" y="6267450"/>
+            <a:ext cx="342900" cy="342900"/>
+          </a:xfrm>
+          <a:prstGeom xmlns:a="http://schemas.openxmlformats.org/drawingml/2006/main" prst="rect">
+            <a:avLst/>
+          </a:prstGeom>
+        </p:spPr>
+      </p:pic>
     </p:spTree>
     <p:extLst>
       <p:ext uri="{BB962C8B-B14F-4D97-AF65-F5344CB8AC3E}">
@@ -5911,6 +5983,30 @@
           </a:p>
         </p:txBody>
       </p:sp>
+      <p:pic>
+        <p:nvPicPr>
+          <p:cNvPr id="24" name="LRDL HHZ logo"/>
+          <p:cNvPicPr>
+            <a:picLocks xmlns:a="http://schemas.openxmlformats.org/drawingml/2006/main" noChangeAspect="1"/>
+          </p:cNvPicPr>
+          <p:nvPr/>
+        </p:nvPicPr>
+        <p:blipFill>
+          <a:blip xmlns:a="http://schemas.openxmlformats.org/drawingml/2006/main" xmlns:r="http://schemas.openxmlformats.org/officeDocument/2006/relationships" r:embed="rIdLrdlLogo"/>
+          <a:stretch xmlns:a="http://schemas.openxmlformats.org/drawingml/2006/main">
+            <a:fillRect/>
+          </a:stretch>
+        </p:blipFill>
+        <p:spPr>
+          <a:xfrm xmlns:a="http://schemas.openxmlformats.org/drawingml/2006/main">
+            <a:off x="365760" y="6267450"/>
+            <a:ext cx="342900" cy="342900"/>
+          </a:xfrm>
+          <a:prstGeom xmlns:a="http://schemas.openxmlformats.org/drawingml/2006/main" prst="rect">
+            <a:avLst/>
+          </a:prstGeom>
+        </p:spPr>
+      </p:pic>
     </p:spTree>
     <p:extLst>
       <p:ext uri="{BB962C8B-B14F-4D97-AF65-F5344CB8AC3E}">
@@ -6872,6 +6968,30 @@
           </a:p>
         </p:txBody>
       </p:sp>
+      <p:pic>
+        <p:nvPicPr>
+          <p:cNvPr id="21" name="LRDL HHZ logo"/>
+          <p:cNvPicPr>
+            <a:picLocks xmlns:a="http://schemas.openxmlformats.org/drawingml/2006/main" noChangeAspect="1"/>
+          </p:cNvPicPr>
+          <p:nvPr/>
+        </p:nvPicPr>
+        <p:blipFill>
+          <a:blip xmlns:a="http://schemas.openxmlformats.org/drawingml/2006/main" xmlns:r="http://schemas.openxmlformats.org/officeDocument/2006/relationships" r:embed="rIdLrdlLogo"/>
+          <a:stretch xmlns:a="http://schemas.openxmlformats.org/drawingml/2006/main">
+            <a:fillRect/>
+          </a:stretch>
+        </p:blipFill>
+        <p:spPr>
+          <a:xfrm xmlns:a="http://schemas.openxmlformats.org/drawingml/2006/main">
+            <a:off x="365760" y="6267450"/>
+            <a:ext cx="342900" cy="342900"/>
+          </a:xfrm>
+          <a:prstGeom xmlns:a="http://schemas.openxmlformats.org/drawingml/2006/main" prst="rect">
+            <a:avLst/>
+          </a:prstGeom>
+        </p:spPr>
+      </p:pic>
     </p:spTree>
     <p:extLst>
       <p:ext uri="{BB962C8B-B14F-4D97-AF65-F5344CB8AC3E}">
@@ -7350,6 +7470,30 @@
           </a:p>
         </p:txBody>
       </p:sp>
+      <p:pic>
+        <p:nvPicPr>
+          <p:cNvPr id="13" name="LRDL HHZ logo"/>
+          <p:cNvPicPr>
+            <a:picLocks xmlns:a="http://schemas.openxmlformats.org/drawingml/2006/main" noChangeAspect="1"/>
+          </p:cNvPicPr>
+          <p:nvPr/>
+        </p:nvPicPr>
+        <p:blipFill>
+          <a:blip xmlns:a="http://schemas.openxmlformats.org/drawingml/2006/main" xmlns:r="http://schemas.openxmlformats.org/officeDocument/2006/relationships" r:embed="rIdLrdlLogo"/>
+          <a:stretch xmlns:a="http://schemas.openxmlformats.org/drawingml/2006/main">
+            <a:fillRect/>
+          </a:stretch>
+        </p:blipFill>
+        <p:spPr>
+          <a:xfrm xmlns:a="http://schemas.openxmlformats.org/drawingml/2006/main">
+            <a:off x="365760" y="6267450"/>
+            <a:ext cx="342900" cy="342900"/>
+          </a:xfrm>
+          <a:prstGeom xmlns:a="http://schemas.openxmlformats.org/drawingml/2006/main" prst="rect">
+            <a:avLst/>
+          </a:prstGeom>
+        </p:spPr>
+      </p:pic>
     </p:spTree>
     <p:extLst>
       <p:ext uri="{BB962C8B-B14F-4D97-AF65-F5344CB8AC3E}">
@@ -7828,6 +7972,30 @@
           </a:p>
         </p:txBody>
       </p:sp>
+      <p:pic>
+        <p:nvPicPr>
+          <p:cNvPr id="13" name="LRDL HHZ logo"/>
+          <p:cNvPicPr>
+            <a:picLocks xmlns:a="http://schemas.openxmlformats.org/drawingml/2006/main" noChangeAspect="1"/>
+          </p:cNvPicPr>
+          <p:nvPr/>
+        </p:nvPicPr>
+        <p:blipFill>
+          <a:blip xmlns:a="http://schemas.openxmlformats.org/drawingml/2006/main" xmlns:r="http://schemas.openxmlformats.org/officeDocument/2006/relationships" r:embed="rIdLrdlLogo"/>
+          <a:stretch xmlns:a="http://schemas.openxmlformats.org/drawingml/2006/main">
+            <a:fillRect/>
+          </a:stretch>
+        </p:blipFill>
+        <p:spPr>
+          <a:xfrm xmlns:a="http://schemas.openxmlformats.org/drawingml/2006/main">
+            <a:off x="365760" y="6267450"/>
+            <a:ext cx="342900" cy="342900"/>
+          </a:xfrm>
+          <a:prstGeom xmlns:a="http://schemas.openxmlformats.org/drawingml/2006/main" prst="rect">
+            <a:avLst/>
+          </a:prstGeom>
+        </p:spPr>
+      </p:pic>
     </p:spTree>
     <p:extLst>
       <p:ext uri="{BB962C8B-B14F-4D97-AF65-F5344CB8AC3E}">
@@ -8573,6 +8741,30 @@
           </a:p>
         </p:txBody>
       </p:sp>
+      <p:pic>
+        <p:nvPicPr>
+          <p:cNvPr id="16" name="LRDL HHZ logo"/>
+          <p:cNvPicPr>
+            <a:picLocks xmlns:a="http://schemas.openxmlformats.org/drawingml/2006/main" noChangeAspect="1"/>
+          </p:cNvPicPr>
+          <p:nvPr/>
+        </p:nvPicPr>
+        <p:blipFill>
+          <a:blip xmlns:a="http://schemas.openxmlformats.org/drawingml/2006/main" xmlns:r="http://schemas.openxmlformats.org/officeDocument/2006/relationships" r:embed="rIdLrdlLogo"/>
+          <a:stretch xmlns:a="http://schemas.openxmlformats.org/drawingml/2006/main">
+            <a:fillRect/>
+          </a:stretch>
+        </p:blipFill>
+        <p:spPr>
+          <a:xfrm xmlns:a="http://schemas.openxmlformats.org/drawingml/2006/main">
+            <a:off x="365760" y="6267450"/>
+            <a:ext cx="342900" cy="342900"/>
+          </a:xfrm>
+          <a:prstGeom xmlns:a="http://schemas.openxmlformats.org/drawingml/2006/main" prst="rect">
+            <a:avLst/>
+          </a:prstGeom>
+        </p:spPr>
+      </p:pic>
     </p:spTree>
     <p:extLst>
       <p:ext uri="{BB962C8B-B14F-4D97-AF65-F5344CB8AC3E}">
@@ -9334,6 +9526,30 @@
           </a:p>
         </p:txBody>
       </p:sp>
+      <p:pic>
+        <p:nvPicPr>
+          <p:cNvPr id="17" name="LRDL HHZ logo"/>
+          <p:cNvPicPr>
+            <a:picLocks xmlns:a="http://schemas.openxmlformats.org/drawingml/2006/main" noChangeAspect="1"/>
+          </p:cNvPicPr>
+          <p:nvPr/>
+        </p:nvPicPr>
+        <p:blipFill>
+          <a:blip xmlns:a="http://schemas.openxmlformats.org/drawingml/2006/main" xmlns:r="http://schemas.openxmlformats.org/officeDocument/2006/relationships" r:embed="rIdLrdlLogo"/>
+          <a:stretch xmlns:a="http://schemas.openxmlformats.org/drawingml/2006/main">
+            <a:fillRect/>
+          </a:stretch>
+        </p:blipFill>
+        <p:spPr>
+          <a:xfrm xmlns:a="http://schemas.openxmlformats.org/drawingml/2006/main">
+            <a:off x="365760" y="6267450"/>
+            <a:ext cx="342900" cy="342900"/>
+          </a:xfrm>
+          <a:prstGeom xmlns:a="http://schemas.openxmlformats.org/drawingml/2006/main" prst="rect">
+            <a:avLst/>
+          </a:prstGeom>
+        </p:spPr>
+      </p:pic>
     </p:spTree>
     <p:extLst>
       <p:ext uri="{BB962C8B-B14F-4D97-AF65-F5344CB8AC3E}">
@@ -10529,6 +10745,30 @@
           </a:p>
         </p:txBody>
       </p:sp>
+      <p:pic>
+        <p:nvPicPr>
+          <p:cNvPr id="25" name="LRDL HHZ logo"/>
+          <p:cNvPicPr>
+            <a:picLocks xmlns:a="http://schemas.openxmlformats.org/drawingml/2006/main" noChangeAspect="1"/>
+          </p:cNvPicPr>
+          <p:nvPr/>
+        </p:nvPicPr>
+        <p:blipFill>
+          <a:blip xmlns:a="http://schemas.openxmlformats.org/drawingml/2006/main" xmlns:r="http://schemas.openxmlformats.org/officeDocument/2006/relationships" r:embed="rIdLrdlLogo"/>
+          <a:stretch xmlns:a="http://schemas.openxmlformats.org/drawingml/2006/main">
+            <a:fillRect/>
+          </a:stretch>
+        </p:blipFill>
+        <p:spPr>
+          <a:xfrm xmlns:a="http://schemas.openxmlformats.org/drawingml/2006/main">
+            <a:off x="365760" y="6267450"/>
+            <a:ext cx="342900" cy="342900"/>
+          </a:xfrm>
+          <a:prstGeom xmlns:a="http://schemas.openxmlformats.org/drawingml/2006/main" prst="rect">
+            <a:avLst/>
+          </a:prstGeom>
+        </p:spPr>
+      </p:pic>
     </p:spTree>
     <p:extLst>
       <p:ext uri="{BB962C8B-B14F-4D97-AF65-F5344CB8AC3E}">

</xml_diff>